<commit_message>
Shrink deck from 605KB to 352KB by right-sizing logo assets
The AWS and GCP logos were embedded at ~900px for shapes drawn at 1-2
inches, and stored as full-colour RGBA. Resizing to the largest on-slide
use at 300dpi and quantising with an alpha-aware octree cuts the media
payload from 336KB to 31KB with no visible change at projector scale.

Co-Authored-By: Claude Opus 5 <noreply@anthropic.com>
Claude-Session: https://claude.ai/code/session_01JLa9ZPKPTxzZAMbop1W6bk
</commit_message>
<xml_diff>
--- a/presentations/Cloud_FinOps_Harel_FY2026_September.pptx
+++ b/presentations/Cloud_FinOps_Harel_FY2026_September.pptx
@@ -147,14 +147,14 @@
   <p:extLst>
     <p:ext uri="{521415D9-36F7-43E2-AB2F-B90AF26B5E84}">
       <p14:sectionLst xmlns:p14="http://schemas.microsoft.com/office/powerpoint/2010/main">
-        <p14:section name="Opening" id="{53f91821-b7e5-a4d5-6b2b-ffbbe65f8b4e}">
+        <p14:section name="Opening" id="{d67c0903-fea8-9978-432a-60272dc119de}">
           <p14:sldIdLst>
             <p14:sldId id="256"/>
             <p14:sldId id="257"/>
             <p14:sldId id="258"/>
           </p14:sldIdLst>
         </p14:section>
-        <p14:section name="01 Where the money goes" id="{a2097e76-4604-bd9e-b63c-e6e11798cd05}">
+        <p14:section name="01 Where the money goes" id="{d451073e-ca12-0afd-2745-42a7d1051bb1}">
           <p14:sldIdLst>
             <p14:sldId id="259"/>
             <p14:sldId id="260"/>
@@ -162,7 +162,7 @@
             <p14:sldId id="262"/>
           </p14:sldIdLst>
         </p14:section>
-        <p14:section name="02 AI and the Factory" id="{741b7339-e771-6058-47f4-27aa455ed0f3}">
+        <p14:section name="02 AI and the Factory" id="{b0409c23-3652-5980-d83e-bd157a222165}">
           <p14:sldIdLst>
             <p14:sldId id="263"/>
             <p14:sldId id="264"/>
@@ -172,7 +172,7 @@
             <p14:sldId id="268"/>
           </p14:sldIdLst>
         </p14:section>
-        <p14:section name="03 AWS" id="{b81e3d62-2d55-173a-e561-7f615b81e7d0}">
+        <p14:section name="03 AWS" id="{e408d859-d9d1-f2a3-4584-2319294d7cbb}">
           <p14:sldIdLst>
             <p14:sldId id="269"/>
             <p14:sldId id="270"/>
@@ -181,7 +181,7 @@
             <p14:sldId id="273"/>
           </p14:sldIdLst>
         </p14:section>
-        <p14:section name="04 Azure" id="{b4de6bb8-afb7-8071-ec19-51a2e20f2331}">
+        <p14:section name="04 Azure" id="{b425db49-c36e-b557-4093-9e915f4373c9}">
           <p14:sldIdLst>
             <p14:sldId id="274"/>
             <p14:sldId id="275"/>
@@ -192,7 +192,7 @@
             <p14:sldId id="280"/>
           </p14:sldIdLst>
         </p14:section>
-        <p14:section name="05 Savings delivered" id="{abaa8b0d-4a09-df86-6377-c6d2c1e60c5c}">
+        <p14:section name="05 Savings delivered" id="{53438a9d-0906-f3d6-e03a-14192694923a}">
           <p14:sldIdLst>
             <p14:sldId id="281"/>
             <p14:sldId id="282"/>
@@ -200,7 +200,7 @@
             <p14:sldId id="284"/>
           </p14:sldIdLst>
         </p14:section>
-        <p14:section name="06 Risks and next steps" id="{1d782143-c953-2689-e302-1cd7427f0409}">
+        <p14:section name="06 Risks and next steps" id="{c7f78c44-e831-f767-9a96-79f8fa115a6c}">
           <p14:sldIdLst>
             <p14:sldId id="285"/>
             <p14:sldId id="286"/>
@@ -209,7 +209,7 @@
             <p14:sldId id="289"/>
           </p14:sldIdLst>
         </p14:section>
-        <p14:section name="Appendix" id="{fd84044a-7f69-b93d-d159-32e4beced02b}">
+        <p14:section name="Appendix" id="{838d5222-b6e9-2395-afb7-18a599f16555}">
           <p14:sldIdLst>
             <p14:sldId id="290"/>
             <p14:sldId id="291"/>

</xml_diff>